<commit_message>
feat: add team member credits to presentations, implement fallback rule-based extraction, add client timeouts, and create panel presentation guide
</commit_message>
<xml_diff>
--- a/Sanjeevani_Lekh_Presentation.pptx
+++ b/Sanjeevani_Lekh_Presentation.pptx
@@ -3309,8 +3309,8 @@
         </p:nvSpPr>
         <p:spPr>
           <a:xfrm>
-            <a:off x="1280160" y="4846320"/>
-            <a:ext cx="9601200" cy="548640"/>
+            <a:off x="1280160" y="4663440"/>
+            <a:ext cx="9601200" cy="914400"/>
           </a:xfrm>
           <a:prstGeom prst="rect">
             <a:avLst/>
@@ -3324,7 +3324,19 @@
           <a:lstStyle/>
           <a:p>
             <a:pPr>
-              <a:defRPr sz="1300">
+              <a:defRPr sz="1300" b="1">
+                <a:solidFill>
+                  <a:srgbClr val="38BDF8"/>
+                </a:solidFill>
+              </a:defRPr>
+            </a:pPr>
+            <a:r>
+              <a:t>Team: Milind Verma • Nikhil Agrawal • Gaurav Kumar • Riya Mehta | Virtusa Jatayu 2026</a:t>
+            </a:r>
+          </a:p>
+          <a:p>
+            <a:pPr>
+              <a:defRPr sz="1200">
                 <a:solidFill>
                   <a:srgbClr val="34D399"/>
                 </a:solidFill>
@@ -4913,6 +4925,41 @@
             <a:br/>
             <a:r>
               <a:t>Multilingual paramedic model extensions with Whisper fine-tuning for regional languages.</a:t>
+            </a:r>
+          </a:p>
+        </p:txBody>
+      </p:sp>
+      <p:sp>
+        <p:nvSpPr>
+          <p:cNvPr id="11" name="TextBox 10"/>
+          <p:cNvSpPr txBox="1"/>
+          <p:nvPr/>
+        </p:nvSpPr>
+        <p:spPr>
+          <a:xfrm>
+            <a:off x="731520" y="6309360"/>
+            <a:ext cx="10698480" cy="365760"/>
+          </a:xfrm>
+          <a:prstGeom prst="rect">
+            <a:avLst/>
+          </a:prstGeom>
+          <a:noFill/>
+        </p:spPr>
+        <p:txBody>
+          <a:bodyPr wrap="none">
+            <a:spAutoFit/>
+          </a:bodyPr>
+          <a:lstStyle/>
+          <a:p>
+            <a:pPr>
+              <a:defRPr sz="1200" b="1">
+                <a:solidFill>
+                  <a:srgbClr val="38BDF8"/>
+                </a:solidFill>
+              </a:defRPr>
+            </a:pPr>
+            <a:r>
+              <a:t>Thank You! Questions &amp; Live Demo Welcome. | Presented by: Milind Verma • Nikhil Agrawal • Gaurav Kumar • Riya Mehta</a:t>
             </a:r>
           </a:p>
         </p:txBody>

</xml_diff>